<commit_message>
Mark the $LOYAL model as not shipped on the RU forecast and tokenomics slides
The growth-economics slide projected revenue from staking and swap fees, and the
tokenomics slide presented $LOYAL allocation, staking and DAO as current. None of
that is deployed — there is no LOYAL contract on Base — so both slides now say so
and point at the live model (subscriptions + pay-per-call in USDC).

Rebuilds the RU PDFs and PPTX from the corrected sources, and adds build_pitch_ru.py
so the RU PDFs can be regenerated the same way build_pitch_en.py handles the EN deck.

Co-authored-by: Cursor <cursoragent@cursor.com>
</commit_message>
<xml_diff>
--- a/docs/pitch-deck/ru/LoyalSpark_Pitch_RU.pptx
+++ b/docs/pitch-deck/ru/LoyalSpark_Pitch_RU.pptx
@@ -4071,7 +4071,7 @@
                 </a:solidFill>
                 <a:latin typeface="Inter"/>
               </a:rPr>
-              <a:t>SaaS бизнеса + API агентов + % mint fee — диверсификация.</a:t>
+              <a:t>SaaS бизнеса + API агентов + x402 оплата за вызов — диверсификация в USDC.</a:t>
             </a:r>
           </a:p>
         </p:txBody>
@@ -5268,7 +5268,7 @@
                 </a:solidFill>
                 <a:latin typeface="Inter"/>
               </a:rPr>
-              <a:t>23 REST + 28 MCP</a:t>
+              <a:t>28 REST + 39 MCP</a:t>
             </a:r>
           </a:p>
         </p:txBody>
@@ -5313,7 +5313,7 @@
                 </a:solidFill>
                 <a:latin typeface="Inter"/>
               </a:rPr>
-              <a:t>инструментов для агентов (+11 recipient MCP)</a:t>
+              <a:t>инструментов для агентов (+20 recipient MCP)</a:t>
             </a:r>
           </a:p>
         </p:txBody>
@@ -7001,7 +7001,7 @@
                 </a:solidFill>
                 <a:latin typeface="Inter"/>
               </a:rPr>
-              <a:t>Сценарий на базе модели стейкинга и транзакционных комиссий.</a:t>
+              <a:t>Сценарий на базе модели стейкинга и транзакционных комиссий — она ещё не задеплоена.</a:t>
             </a:r>
           </a:p>
         </p:txBody>
@@ -8122,7 +8122,7 @@
                 </a:solidFill>
                 <a:latin typeface="Inter"/>
               </a:rPr>
-              <a:t>Прогноз иллюстративный: целевая траектория при достижении PMF и активации канала агентов.</a:t>
+              <a:t>Прогноз иллюстративный: целевая траектория при достижении PMF и активации канала агентов. Опирается на будущую модель $LOYAL, а не на текущую выручку (подписки и оплата за вызов в USDC).</a:t>
             </a:r>
           </a:p>
         </p:txBody>
@@ -8402,7 +8402,7 @@
                 </a:solidFill>
                 <a:latin typeface="Inter"/>
               </a:rPr>
-              <a:t>LOYAL — топливо экосистемы</a:t>
+              <a:t>LOYAL — топливо экосистемы (план)</a:t>
             </a:r>
           </a:p>
         </p:txBody>
@@ -9808,6 +9808,51 @@
         </p:nvSpPr>
         <p:spPr>
           <a:xfrm>
+            <a:off x="822960" y="6053328"/>
+            <a:ext cx="10515600" cy="320040"/>
+          </a:xfrm>
+          <a:prstGeom prst="rect">
+            <a:avLst/>
+          </a:prstGeom>
+          <a:noFill/>
+        </p:spPr>
+        <p:txBody>
+          <a:bodyPr wrap="square" anchor="t" lIns="0" rIns="0" tIns="0" bIns="0">
+            <a:spAutoFit/>
+          </a:bodyPr>
+          <a:lstStyle/>
+          <a:p>
+            <a:pPr algn="l">
+              <a:lnSpc>
+                <a:spcPct val="100000"/>
+              </a:lnSpc>
+              <a:spcBef>
+                <a:spcPts val="0"/>
+              </a:spcBef>
+              <a:spcAft>
+                <a:spcPts val="600"/>
+              </a:spcAft>
+            </a:pPr>
+            <a:r>
+              <a:rPr sz="1150" b="0">
+                <a:solidFill>
+                  <a:srgbClr val="9AA7C7"/>
+                </a:solidFill>
+                <a:latin typeface="Inter"/>
+              </a:rPr>
+              <a:t>$LOYAL, стейкинг и DAO пока не задеплоены — дизайн следующей фазы. Сейчас: подписки и оплата за вызов в USDC.</a:t>
+            </a:r>
+          </a:p>
+        </p:txBody>
+      </p:sp>
+      <p:sp>
+        <p:nvSpPr>
+          <p:cNvPr id="36" name="TextBox 35"/>
+          <p:cNvSpPr txBox="1"/>
+          <p:nvPr/>
+        </p:nvSpPr>
+        <p:spPr>
+          <a:xfrm>
             <a:off x="822960" y="6446520"/>
             <a:ext cx="3657600" cy="320040"/>
           </a:xfrm>
@@ -9865,7 +9910,7 @@
       </p:sp>
       <p:sp>
         <p:nvSpPr>
-          <p:cNvPr id="36" name="TextBox 35"/>
+          <p:cNvPr id="37" name="TextBox 36"/>
           <p:cNvSpPr txBox="1"/>
           <p:nvPr/>
         </p:nvSpPr>
@@ -15487,7 +15532,7 @@
                 </a:solidFill>
                 <a:latin typeface="Inter"/>
               </a:rPr>
-              <a:t>$200B+</a:t>
+              <a:t>~$16B</a:t>
             </a:r>
           </a:p>
         </p:txBody>
@@ -15532,7 +15577,7 @@
                 </a:solidFill>
                 <a:latin typeface="Inter"/>
               </a:rPr>
-              <a:t>TAM — глобальный рынок лояльности (SaaS + обязательства по баллам)</a:t>
+              <a:t>TAM — глобальный рынок loyalty management (2026)</a:t>
             </a:r>
           </a:p>
         </p:txBody>
@@ -15625,7 +15670,7 @@
                 </a:solidFill>
                 <a:latin typeface="Inter"/>
               </a:rPr>
-              <a:t>$60B</a:t>
+              <a:t>~$5B</a:t>
             </a:r>
           </a:p>
         </p:txBody>
@@ -15670,7 +15715,7 @@
                 </a:solidFill>
                 <a:latin typeface="Inter"/>
               </a:rPr>
-              <a:t>SAM — цифровая лояльность SMB и mid-market</a:t>
+              <a:t>SAM — цифровая / cloud-лояльность SMB и mid-market</a:t>
             </a:r>
           </a:p>
         </p:txBody>
@@ -15946,7 +15991,7 @@
                 </a:solidFill>
                 <a:latin typeface="Inter"/>
               </a:rPr>
-              <a:t>баллов выпускается и не погашается ежегодно</a:t>
+              <a:t>обязательств по неиспользованным баллам лояльности глобально</a:t>
             </a:r>
           </a:p>
         </p:txBody>
@@ -15991,7 +16036,7 @@
                 </a:solidFill>
                 <a:latin typeface="Inter"/>
               </a:rPr>
-              <a:t>Источники: отраслевые отчёты по рынку лояльности и SMB-коммерции. SAM — обслуживаемый сегмент цифровой лояльности.</a:t>
+              <a:t>Источники: Mordor / Grand View и др. по loyalty management (~$15–16B в 2026). SAM — консервативная оценка SMB / mid-market digital &amp; cloud.</a:t>
             </a:r>
           </a:p>
         </p:txBody>
@@ -19837,7 +19882,7 @@
                 </a:solidFill>
                 <a:latin typeface="Inter"/>
               </a:rPr>
-              <a:t>Pay-per-call (x402 / MPP): от ~$0.001 за чтение, ~$0.005–0.05 за запись. Главный рычаг масштабирования — % mint fee с onchain-оборота.</a:t>
+              <a:t>Pay-per-call (x402 / MPP): от ~$0.001 за чтение, ~$0.005–0.05 за запись. Денежная выручка — подписки и оплата за вызов (предоплата в USDC). Mint fee списывается в баллах мерчанта — протокольный учёт, не ARR.</a:t>
             </a:r>
           </a:p>
         </p:txBody>

</xml_diff>

<commit_message>
Align tokenomics with final Vibestarter allocation and drop staking.
Replace the old 10B / staking / burn model with the fixed 1B Vibestarter split so investor docs match the launch contract.

Co-authored-by: Cursor <cursoragent@cursor.com>
</commit_message>
<xml_diff>
--- a/docs/pitch-deck/ru/LoyalSpark_Pitch_RU.pptx
+++ b/docs/pitch-deck/ru/LoyalSpark_Pitch_RU.pptx
@@ -4597,7 +4597,7 @@
                 </a:solidFill>
                 <a:latin typeface="Inter"/>
               </a:rPr>
-              <a:t>Сетевой эффект LOYAL</a:t>
+              <a:t>Токен у сообщества</a:t>
             </a:r>
           </a:p>
           <a:p>
@@ -4619,7 +4619,7 @@
                 </a:solidFill>
                 <a:latin typeface="Inter"/>
               </a:rPr>
-              <a:t>Hub-and-spoke ликвидность объединяет все токены лояльности.</a:t>
+              <a:t>65% $LOYAL — участникам, ликвидность залочена навсегда.</a:t>
             </a:r>
           </a:p>
         </p:txBody>
@@ -7001,7 +7001,7 @@
                 </a:solidFill>
                 <a:latin typeface="Inter"/>
               </a:rPr>
-              <a:t>Сценарий на базе модели стейкинга и транзакционных комиссий — она ещё не задеплоена.</a:t>
+              <a:t>Сценарий на базе подписок в USDC и оплаты за вызов (x402 / MPP) — модель работает уже сегодня.</a:t>
             </a:r>
           </a:p>
         </p:txBody>
@@ -7494,7 +7494,7 @@
                 </a:solidFill>
                 <a:latin typeface="Inter"/>
               </a:rPr>
-              <a:t>Total Value Locked</a:t>
+              <a:t>Объём транзакций</a:t>
             </a:r>
           </a:p>
         </p:txBody>
@@ -7539,7 +7539,7 @@
                 </a:solidFill>
                 <a:latin typeface="Inter"/>
               </a:rPr>
-              <a:t>$2M</a:t>
+              <a:t>$500K</a:t>
             </a:r>
           </a:p>
         </p:txBody>
@@ -7584,7 +7584,7 @@
                 </a:solidFill>
                 <a:latin typeface="Inter"/>
               </a:rPr>
-              <a:t>$25M</a:t>
+              <a:t>$10M</a:t>
             </a:r>
           </a:p>
         </p:txBody>
@@ -7629,7 +7629,7 @@
                 </a:solidFill>
                 <a:latin typeface="Inter"/>
               </a:rPr>
-              <a:t>$150M</a:t>
+              <a:t>$100M</a:t>
             </a:r>
           </a:p>
         </p:txBody>
@@ -7718,7 +7718,7 @@
                 </a:solidFill>
                 <a:latin typeface="Inter"/>
               </a:rPr>
-              <a:t>Объём транзакций</a:t>
+              <a:t>Выручка протокола</a:t>
             </a:r>
           </a:p>
         </p:txBody>
@@ -7763,7 +7763,7 @@
                 </a:solidFill>
                 <a:latin typeface="Inter"/>
               </a:rPr>
-              <a:t>$500K</a:t>
+              <a:t>$50K</a:t>
             </a:r>
           </a:p>
         </p:txBody>
@@ -7808,7 +7808,7 @@
                 </a:solidFill>
                 <a:latin typeface="Inter"/>
               </a:rPr>
-              <a:t>$10M</a:t>
+              <a:t>$1.5M</a:t>
             </a:r>
           </a:p>
         </p:txBody>
@@ -7853,52 +7853,53 @@
                 </a:solidFill>
                 <a:latin typeface="Inter"/>
               </a:rPr>
-              <a:t>$100M</a:t>
-            </a:r>
-          </a:p>
-        </p:txBody>
-      </p:sp>
-      <p:sp>
-        <p:nvSpPr>
-          <p:cNvPr id="25" name="Rectangle 24"/>
-          <p:cNvSpPr/>
-          <p:nvPr/>
-        </p:nvSpPr>
-        <p:spPr>
-          <a:xfrm>
-            <a:off x="822960" y="4974336"/>
-            <a:ext cx="10515600" cy="9525"/>
-          </a:xfrm>
-          <a:prstGeom prst="rect">
-            <a:avLst/>
-          </a:prstGeom>
-          <a:solidFill>
-            <a:srgbClr val="2A355E"/>
-          </a:solidFill>
-          <a:ln>
-            <a:noFill/>
-          </a:ln>
-          <a:effectLst/>
-        </p:spPr>
-        <p:style>
-          <a:lnRef idx="1">
-            <a:schemeClr val="accent1"/>
-          </a:lnRef>
-          <a:fillRef idx="3">
-            <a:schemeClr val="accent1"/>
-          </a:fillRef>
-          <a:effectRef idx="2">
-            <a:schemeClr val="accent1"/>
-          </a:effectRef>
-          <a:fontRef idx="minor">
-            <a:schemeClr val="lt1"/>
-          </a:fontRef>
-        </p:style>
-        <p:txBody>
-          <a:bodyPr rtlCol="0" anchor="ctr"/>
-          <a:lstStyle/>
-          <a:p>
-            <a:pPr algn="ctr"/>
+              <a:t>$12M</a:t>
+            </a:r>
+          </a:p>
+        </p:txBody>
+      </p:sp>
+      <p:sp>
+        <p:nvSpPr>
+          <p:cNvPr id="25" name="TextBox 24"/>
+          <p:cNvSpPr txBox="1"/>
+          <p:nvPr/>
+        </p:nvSpPr>
+        <p:spPr>
+          <a:xfrm>
+            <a:off x="822960" y="5943600"/>
+            <a:ext cx="10515600" cy="457200"/>
+          </a:xfrm>
+          <a:prstGeom prst="rect">
+            <a:avLst/>
+          </a:prstGeom>
+          <a:noFill/>
+        </p:spPr>
+        <p:txBody>
+          <a:bodyPr wrap="square" anchor="t" lIns="0" rIns="0" tIns="0" bIns="0">
+            <a:spAutoFit/>
+          </a:bodyPr>
+          <a:lstStyle/>
+          <a:p>
+            <a:pPr algn="l">
+              <a:lnSpc>
+                <a:spcPct val="100000"/>
+              </a:lnSpc>
+              <a:spcBef>
+                <a:spcPts val="0"/>
+              </a:spcBef>
+              <a:spcAft>
+                <a:spcPts val="600"/>
+              </a:spcAft>
+            </a:pPr>
+            <a:r>
+              <a:rPr sz="1150" b="0">
+                <a:solidFill>
+                  <a:srgbClr val="9AA7C7"/>
+                </a:solidFill>
+                <a:latin typeface="Inter"/>
+              </a:rPr>
+              <a:t>Прогноз иллюстративный: целевая траектория при достижении PMF и активации канала агентов. Выручка считается по платящим подписчикам и оплате за вызов, часть бизнесов остаётся на бесплатном тарифе. $LOYAL в прогноз не входит.</a:t>
+            </a:r>
           </a:p>
         </p:txBody>
       </p:sp>
@@ -7910,8 +7911,8 @@
         </p:nvSpPr>
         <p:spPr>
           <a:xfrm>
-            <a:off x="822960" y="5084064"/>
-            <a:ext cx="2377440" cy="457200"/>
+            <a:off x="822960" y="6446520"/>
+            <a:ext cx="3657600" cy="320040"/>
           </a:xfrm>
           <a:prstGeom prst="rect">
             <a:avLst/>
@@ -7936,13 +7937,31 @@
               </a:spcAft>
             </a:pPr>
             <a:r>
-              <a:rPr sz="1500" b="1">
+              <a:rPr sz="1100" b="1">
+                <a:solidFill>
+                  <a:srgbClr val="EEF2FF"/>
+                </a:solidFill>
+                <a:latin typeface="Inter"/>
+              </a:rPr>
+              <a:t>Loyal</a:t>
+            </a:r>
+            <a:r>
+              <a:rPr sz="1100" b="1">
+                <a:solidFill>
+                  <a:srgbClr val="5B8CFF"/>
+                </a:solidFill>
+                <a:latin typeface="Inter"/>
+              </a:rPr>
+              <a:t>Spark</a:t>
+            </a:r>
+            <a:r>
+              <a:rPr sz="1100" b="0">
                 <a:solidFill>
                   <a:srgbClr val="9AA7C7"/>
                 </a:solidFill>
                 <a:latin typeface="Inter"/>
               </a:rPr>
-              <a:t>Выручка протокола</a:t>
+              <a:t>  ·  Onchain Loyalty Protocol</a:t>
             </a:r>
           </a:p>
         </p:txBody>
@@ -7950,249 +7969,6 @@
       <p:sp>
         <p:nvSpPr>
           <p:cNvPr id="27" name="TextBox 26"/>
-          <p:cNvSpPr txBox="1"/>
-          <p:nvPr/>
-        </p:nvSpPr>
-        <p:spPr>
-          <a:xfrm>
-            <a:off x="4572000" y="5084064"/>
-            <a:ext cx="2377440" cy="457200"/>
-          </a:xfrm>
-          <a:prstGeom prst="rect">
-            <a:avLst/>
-          </a:prstGeom>
-          <a:noFill/>
-        </p:spPr>
-        <p:txBody>
-          <a:bodyPr wrap="square" anchor="t" lIns="0" rIns="0" tIns="0" bIns="0">
-            <a:spAutoFit/>
-          </a:bodyPr>
-          <a:lstStyle/>
-          <a:p>
-            <a:pPr algn="l">
-              <a:lnSpc>
-                <a:spcPct val="100000"/>
-              </a:lnSpc>
-              <a:spcBef>
-                <a:spcPts val="0"/>
-              </a:spcBef>
-              <a:spcAft>
-                <a:spcPts val="600"/>
-              </a:spcAft>
-            </a:pPr>
-            <a:r>
-              <a:rPr sz="1500" b="0">
-                <a:solidFill>
-                  <a:srgbClr val="EEF2FF"/>
-                </a:solidFill>
-                <a:latin typeface="Inter"/>
-              </a:rPr>
-              <a:t>$50K</a:t>
-            </a:r>
-          </a:p>
-        </p:txBody>
-      </p:sp>
-      <p:sp>
-        <p:nvSpPr>
-          <p:cNvPr id="28" name="TextBox 27"/>
-          <p:cNvSpPr txBox="1"/>
-          <p:nvPr/>
-        </p:nvSpPr>
-        <p:spPr>
-          <a:xfrm>
-            <a:off x="7040880" y="5084064"/>
-            <a:ext cx="2377440" cy="457200"/>
-          </a:xfrm>
-          <a:prstGeom prst="rect">
-            <a:avLst/>
-          </a:prstGeom>
-          <a:noFill/>
-        </p:spPr>
-        <p:txBody>
-          <a:bodyPr wrap="square" anchor="t" lIns="0" rIns="0" tIns="0" bIns="0">
-            <a:spAutoFit/>
-          </a:bodyPr>
-          <a:lstStyle/>
-          <a:p>
-            <a:pPr algn="l">
-              <a:lnSpc>
-                <a:spcPct val="100000"/>
-              </a:lnSpc>
-              <a:spcBef>
-                <a:spcPts val="0"/>
-              </a:spcBef>
-              <a:spcAft>
-                <a:spcPts val="600"/>
-              </a:spcAft>
-            </a:pPr>
-            <a:r>
-              <a:rPr sz="1500" b="0">
-                <a:solidFill>
-                  <a:srgbClr val="EEF2FF"/>
-                </a:solidFill>
-                <a:latin typeface="Inter"/>
-              </a:rPr>
-              <a:t>$1.5M</a:t>
-            </a:r>
-          </a:p>
-        </p:txBody>
-      </p:sp>
-      <p:sp>
-        <p:nvSpPr>
-          <p:cNvPr id="29" name="TextBox 28"/>
-          <p:cNvSpPr txBox="1"/>
-          <p:nvPr/>
-        </p:nvSpPr>
-        <p:spPr>
-          <a:xfrm>
-            <a:off x="9509760" y="5084064"/>
-            <a:ext cx="2377440" cy="457200"/>
-          </a:xfrm>
-          <a:prstGeom prst="rect">
-            <a:avLst/>
-          </a:prstGeom>
-          <a:noFill/>
-        </p:spPr>
-        <p:txBody>
-          <a:bodyPr wrap="square" anchor="t" lIns="0" rIns="0" tIns="0" bIns="0">
-            <a:spAutoFit/>
-          </a:bodyPr>
-          <a:lstStyle/>
-          <a:p>
-            <a:pPr algn="l">
-              <a:lnSpc>
-                <a:spcPct val="100000"/>
-              </a:lnSpc>
-              <a:spcBef>
-                <a:spcPts val="0"/>
-              </a:spcBef>
-              <a:spcAft>
-                <a:spcPts val="600"/>
-              </a:spcAft>
-            </a:pPr>
-            <a:r>
-              <a:rPr sz="1500" b="1">
-                <a:solidFill>
-                  <a:srgbClr val="EEF2FF"/>
-                </a:solidFill>
-                <a:latin typeface="Inter"/>
-              </a:rPr>
-              <a:t>$12M</a:t>
-            </a:r>
-          </a:p>
-        </p:txBody>
-      </p:sp>
-      <p:sp>
-        <p:nvSpPr>
-          <p:cNvPr id="30" name="TextBox 29"/>
-          <p:cNvSpPr txBox="1"/>
-          <p:nvPr/>
-        </p:nvSpPr>
-        <p:spPr>
-          <a:xfrm>
-            <a:off x="822960" y="5943600"/>
-            <a:ext cx="10515600" cy="457200"/>
-          </a:xfrm>
-          <a:prstGeom prst="rect">
-            <a:avLst/>
-          </a:prstGeom>
-          <a:noFill/>
-        </p:spPr>
-        <p:txBody>
-          <a:bodyPr wrap="square" anchor="t" lIns="0" rIns="0" tIns="0" bIns="0">
-            <a:spAutoFit/>
-          </a:bodyPr>
-          <a:lstStyle/>
-          <a:p>
-            <a:pPr algn="l">
-              <a:lnSpc>
-                <a:spcPct val="100000"/>
-              </a:lnSpc>
-              <a:spcBef>
-                <a:spcPts val="0"/>
-              </a:spcBef>
-              <a:spcAft>
-                <a:spcPts val="600"/>
-              </a:spcAft>
-            </a:pPr>
-            <a:r>
-              <a:rPr sz="1150" b="0">
-                <a:solidFill>
-                  <a:srgbClr val="9AA7C7"/>
-                </a:solidFill>
-                <a:latin typeface="Inter"/>
-              </a:rPr>
-              <a:t>Прогноз иллюстративный: целевая траектория при достижении PMF и активации канала агентов. Опирается на будущую модель $LOYAL, а не на текущую выручку (подписки и оплата за вызов в USDC).</a:t>
-            </a:r>
-          </a:p>
-        </p:txBody>
-      </p:sp>
-      <p:sp>
-        <p:nvSpPr>
-          <p:cNvPr id="31" name="TextBox 30"/>
-          <p:cNvSpPr txBox="1"/>
-          <p:nvPr/>
-        </p:nvSpPr>
-        <p:spPr>
-          <a:xfrm>
-            <a:off x="822960" y="6446520"/>
-            <a:ext cx="3657600" cy="320040"/>
-          </a:xfrm>
-          <a:prstGeom prst="rect">
-            <a:avLst/>
-          </a:prstGeom>
-          <a:noFill/>
-        </p:spPr>
-        <p:txBody>
-          <a:bodyPr wrap="square" anchor="t" lIns="0" rIns="0" tIns="0" bIns="0">
-            <a:spAutoFit/>
-          </a:bodyPr>
-          <a:lstStyle/>
-          <a:p>
-            <a:pPr algn="l">
-              <a:lnSpc>
-                <a:spcPct val="100000"/>
-              </a:lnSpc>
-              <a:spcBef>
-                <a:spcPts val="0"/>
-              </a:spcBef>
-              <a:spcAft>
-                <a:spcPts val="600"/>
-              </a:spcAft>
-            </a:pPr>
-            <a:r>
-              <a:rPr sz="1100" b="1">
-                <a:solidFill>
-                  <a:srgbClr val="EEF2FF"/>
-                </a:solidFill>
-                <a:latin typeface="Inter"/>
-              </a:rPr>
-              <a:t>Loyal</a:t>
-            </a:r>
-            <a:r>
-              <a:rPr sz="1100" b="1">
-                <a:solidFill>
-                  <a:srgbClr val="5B8CFF"/>
-                </a:solidFill>
-                <a:latin typeface="Inter"/>
-              </a:rPr>
-              <a:t>Spark</a:t>
-            </a:r>
-            <a:r>
-              <a:rPr sz="1100" b="0">
-                <a:solidFill>
-                  <a:srgbClr val="9AA7C7"/>
-                </a:solidFill>
-                <a:latin typeface="Inter"/>
-              </a:rPr>
-              <a:t>  ·  Onchain Loyalty Protocol</a:t>
-            </a:r>
-          </a:p>
-        </p:txBody>
-      </p:sp>
-      <p:sp>
-        <p:nvSpPr>
-          <p:cNvPr id="32" name="TextBox 31"/>
           <p:cNvSpPr txBox="1"/>
           <p:nvPr/>
         </p:nvSpPr>
@@ -8402,7 +8178,7 @@
                 </a:solidFill>
                 <a:latin typeface="Inter"/>
               </a:rPr>
-              <a:t>LOYAL — топливо экосистемы (план)</a:t>
+              <a:t>LOYAL — управление и ликвидность</a:t>
             </a:r>
           </a:p>
         </p:txBody>
@@ -8495,7 +8271,7 @@
                 </a:solidFill>
                 <a:latin typeface="Inter"/>
               </a:rPr>
-              <a:t>Распределение · 10 000 000 000 LOYAL</a:t>
+              <a:t>Распределение · 1 000 000 000 LOYAL</a:t>
             </a:r>
           </a:p>
         </p:txBody>
@@ -8540,7 +8316,7 @@
                 </a:solidFill>
                 <a:latin typeface="Inter"/>
               </a:rPr>
-              <a:t>Экосистема / Treasury</a:t>
+              <a:t>Backers</a:t>
             </a:r>
           </a:p>
         </p:txBody>
@@ -8585,7 +8361,7 @@
                 </a:solidFill>
                 <a:latin typeface="Inter"/>
               </a:rPr>
-              <a:t>41%</a:t>
+              <a:t>65.0%</a:t>
             </a:r>
           </a:p>
         </p:txBody>
@@ -8645,7 +8421,7 @@
         <p:spPr>
           <a:xfrm>
             <a:off x="1051560" y="3264408"/>
-            <a:ext cx="1949500" cy="128016"/>
+            <a:ext cx="3090672" cy="128016"/>
           </a:xfrm>
           <a:prstGeom prst="roundRect">
             <a:avLst>
@@ -8722,7 +8498,7 @@
                 </a:solidFill>
                 <a:latin typeface="Inter"/>
               </a:rPr>
-              <a:t>Token Sales</a:t>
+              <a:t>Ликвидность (навсегда)</a:t>
             </a:r>
           </a:p>
         </p:txBody>
@@ -8767,7 +8543,7 @@
                 </a:solidFill>
                 <a:latin typeface="Inter"/>
               </a:rPr>
-              <a:t>30%</a:t>
+              <a:t>15.0%</a:t>
             </a:r>
           </a:p>
         </p:txBody>
@@ -8827,7 +8603,7 @@
         <p:spPr>
           <a:xfrm>
             <a:off x="1051560" y="3831336"/>
-            <a:ext cx="1426464" cy="128016"/>
+            <a:ext cx="713232" cy="128016"/>
           </a:xfrm>
           <a:prstGeom prst="roundRect">
             <a:avLst>
@@ -8904,7 +8680,7 @@
                 </a:solidFill>
                 <a:latin typeface="Inter"/>
               </a:rPr>
-              <a:t>Команда и эдвайзеры</a:t>
+              <a:t>Treasury (governance)</a:t>
             </a:r>
           </a:p>
         </p:txBody>
@@ -8949,7 +8725,7 @@
                 </a:solidFill>
                 <a:latin typeface="Inter"/>
               </a:rPr>
-              <a:t>20%</a:t>
+              <a:t>10.0%</a:t>
             </a:r>
           </a:p>
         </p:txBody>
@@ -9009,7 +8785,7 @@
         <p:spPr>
           <a:xfrm>
             <a:off x="1051560" y="4398264"/>
-            <a:ext cx="950976" cy="128016"/>
+            <a:ext cx="475488" cy="128016"/>
           </a:xfrm>
           <a:prstGeom prst="roundRect">
             <a:avLst>
@@ -9086,7 +8862,7 @@
                 </a:solidFill>
                 <a:latin typeface="Inter"/>
               </a:rPr>
-              <a:t>Ликвидность (IDL)</a:t>
+              <a:t>Founder (time-lock)</a:t>
             </a:r>
           </a:p>
         </p:txBody>
@@ -9131,7 +8907,7 @@
                 </a:solidFill>
                 <a:latin typeface="Inter"/>
               </a:rPr>
-              <a:t>5%</a:t>
+              <a:t>7.5%</a:t>
             </a:r>
           </a:p>
         </p:txBody>
@@ -9191,7 +8967,7 @@
         <p:spPr>
           <a:xfrm>
             <a:off x="1051560" y="4965192"/>
-            <a:ext cx="237744" cy="128016"/>
+            <a:ext cx="356616" cy="128016"/>
           </a:xfrm>
           <a:prstGeom prst="roundRect">
             <a:avLst>
@@ -9268,7 +9044,7 @@
                 </a:solidFill>
                 <a:latin typeface="Inter"/>
               </a:rPr>
-              <a:t>Маркетинг / Airdrop</a:t>
+              <a:t>Экосистема / Airdrop</a:t>
             </a:r>
           </a:p>
         </p:txBody>
@@ -9313,7 +9089,7 @@
                 </a:solidFill>
                 <a:latin typeface="Inter"/>
               </a:rPr>
-              <a:t>4%</a:t>
+              <a:t>2.5%</a:t>
             </a:r>
           </a:p>
         </p:txBody>
@@ -9373,7 +9149,7 @@
         <p:spPr>
           <a:xfrm>
             <a:off x="1051560" y="5532120"/>
-            <a:ext cx="190195" cy="128016"/>
+            <a:ext cx="118872" cy="128016"/>
           </a:xfrm>
           <a:prstGeom prst="roundRect">
             <a:avLst>
@@ -9498,7 +9274,7 @@
                 </a:solidFill>
                 <a:latin typeface="Inter"/>
               </a:rPr>
-              <a:t>Утилитарность и дефляция</a:t>
+              <a:t>Что это даёт</a:t>
             </a:r>
           </a:p>
         </p:txBody>
@@ -9543,7 +9319,7 @@
                 </a:solidFill>
                 <a:latin typeface="Inter"/>
               </a:rPr>
-              <a:t>🔥</a:t>
+              <a:t>🤝</a:t>
             </a:r>
           </a:p>
         </p:txBody>
@@ -9588,7 +9364,7 @@
                 </a:solidFill>
                 <a:latin typeface="Inter"/>
               </a:rPr>
-              <a:t>Дефляция. </a:t>
+              <a:t>65% — участникам. </a:t>
             </a:r>
             <a:r>
               <a:rPr sz="1250" b="0">
@@ -9597,7 +9373,7 @@
                 </a:solidFill>
                 <a:latin typeface="Inter"/>
               </a:rPr>
-              <a:t>8% сжигается при выводе баллов (M-token → LOYAL), защищая цену.</a:t>
+              <a:t>Основатель ограничен 7.5% на уровне контракта, поднять нельзя.</a:t>
             </a:r>
           </a:p>
         </p:txBody>
@@ -9642,7 +9418,7 @@
                 </a:solidFill>
                 <a:latin typeface="Inter"/>
               </a:rPr>
-              <a:t>🏦</a:t>
+              <a:t>🔒</a:t>
             </a:r>
           </a:p>
         </p:txBody>
@@ -9687,7 +9463,7 @@
                 </a:solidFill>
                 <a:latin typeface="Inter"/>
               </a:rPr>
-              <a:t>Залог-стейкинг. </a:t>
+              <a:t>Ликвидность не вывести. </a:t>
             </a:r>
             <a:r>
               <a:rPr sz="1250" b="0">
@@ -9696,7 +9472,7 @@
                 </a:solidFill>
                 <a:latin typeface="Inter"/>
               </a:rPr>
-              <a:t>Возвратный депозит для доступа и ликвидности (от $1 000).</a:t>
+              <a:t>15% залочены в Aerodrome навсегда — вектор rug закрыт.</a:t>
             </a:r>
           </a:p>
         </p:txBody>
@@ -9786,7 +9562,7 @@
                 </a:solidFill>
                 <a:latin typeface="Inter"/>
               </a:rPr>
-              <a:t>Управление DAO. </a:t>
+              <a:t>Governance без стейкинга. </a:t>
             </a:r>
             <a:r>
               <a:rPr sz="1250" b="0">
@@ -9795,7 +9571,7 @@
                 </a:solidFill>
                 <a:latin typeface="Inter"/>
               </a:rPr>
-              <a:t>Застейканный LOYAL даёт право голоса по параметрам протокола.</a:t>
+              <a:t>Treasury разблокируется только голосованием держателей.</a:t>
             </a:r>
           </a:p>
         </p:txBody>
@@ -9840,7 +9616,7 @@
                 </a:solidFill>
                 <a:latin typeface="Inter"/>
               </a:rPr>
-              <a:t>$LOYAL, стейкинг и DAO пока не задеплоены — дизайн следующей фазы. Сейчас: подписки и оплата за вызов в USDC.</a:t>
+              <a:t>Запуск на Vibestarter (Base) — аллокация зашита в контракт при деплое. Выручка платформы — подписки и оплата за вызов в USDC: $LOYAL не используется для оплаты сервиса, продукт не зависит от цены токена.</a:t>
             </a:r>
           </a:p>
         </p:txBody>
@@ -11861,7 +11637,7 @@
                 </a:solidFill>
                 <a:latin typeface="Inter"/>
               </a:rPr>
-              <a:t>🔒</a:t>
+              <a:t>💵</a:t>
             </a:r>
           </a:p>
           <a:p>
@@ -11883,7 +11659,7 @@
                 </a:solidFill>
                 <a:latin typeface="Inter"/>
               </a:rPr>
-              <a:t>$2M+ TVL</a:t>
+              <a:t>Регулярная выручка</a:t>
             </a:r>
           </a:p>
           <a:p>
@@ -11905,7 +11681,7 @@
                 </a:solidFill>
                 <a:latin typeface="Inter"/>
               </a:rPr>
-              <a:t>Заблокировано в стейках бизнесов.</a:t>
+              <a:t>Подписки и оплата за вызов в USDC.</a:t>
             </a:r>
           </a:p>
         </p:txBody>

</xml_diff>